<commit_message>
secure production delivery and split public installer
</commit_message>
<xml_diff>
--- a/production-library/templates/settled/disease-health-shenke-blue-v1/generator/急性上呼吸道感染_疾病健康知识培训_可编辑金样_v3.pptx
+++ b/production-library/templates/settled/disease-health-shenke-blue-v1/generator/急性上呼吸道感染_疾病健康知识培训_可编辑金样_v3.pptx
@@ -8213,8 +8213,8 @@
         </p:nvSpPr>
         <p:spPr>
           <a:xfrm>
-            <a:off x="365760" y="1005840"/>
-            <a:ext cx="11430000" cy="960120"/>
+            <a:off x="411480" y="1005840"/>
+            <a:ext cx="11338560" cy="960120"/>
           </a:xfrm>
           <a:prstGeom prst="roundRect">
             <a:avLst>
@@ -8240,8 +8240,8 @@
         </p:nvSpPr>
         <p:spPr>
           <a:xfrm>
-            <a:off x="594360" y="1078992"/>
-            <a:ext cx="10972800" cy="822960"/>
+            <a:off x="640080" y="1078992"/>
+            <a:ext cx="10881360" cy="822960"/>
           </a:xfrm>
           <a:prstGeom prst="rect">
             <a:avLst/>
@@ -14254,7 +14254,7 @@
         </p:nvSpPr>
         <p:spPr>
           <a:xfrm>
-            <a:off x="365760" y="1042416"/>
+            <a:off x="411480" y="1042416"/>
             <a:ext cx="7040880" cy="1408176"/>
           </a:xfrm>
           <a:prstGeom prst="roundRect">
@@ -14288,7 +14288,7 @@
         </p:nvSpPr>
         <p:spPr>
           <a:xfrm>
-            <a:off x="365760" y="1042416"/>
+            <a:off x="411480" y="1042416"/>
             <a:ext cx="7040880" cy="384048"/>
           </a:xfrm>
           <a:prstGeom prst="roundRect">
@@ -14310,7 +14310,7 @@
         </p:nvSpPr>
         <p:spPr>
           <a:xfrm>
-            <a:off x="365760" y="1298448"/>
+            <a:off x="411480" y="1298448"/>
             <a:ext cx="7040880" cy="146304"/>
           </a:xfrm>
           <a:prstGeom prst="rect">
@@ -14330,7 +14330,7 @@
         </p:nvSpPr>
         <p:spPr>
           <a:xfrm>
-            <a:off x="365760" y="1042416"/>
+            <a:off x="411480" y="1042416"/>
             <a:ext cx="109728" cy="384048"/>
           </a:xfrm>
           <a:prstGeom prst="rect">
@@ -14350,7 +14350,7 @@
         </p:nvSpPr>
         <p:spPr>
           <a:xfrm>
-            <a:off x="594360" y="1042416"/>
+            <a:off x="640080" y="1042416"/>
             <a:ext cx="6583680" cy="384048"/>
           </a:xfrm>
           <a:prstGeom prst="rect">
@@ -14389,7 +14389,7 @@
         </p:nvSpPr>
         <p:spPr>
           <a:xfrm>
-            <a:off x="548640" y="1499616"/>
+            <a:off x="594360" y="1499616"/>
             <a:ext cx="6675120" cy="877824"/>
           </a:xfrm>
           <a:prstGeom prst="rect">
@@ -14428,7 +14428,7 @@
         </p:nvSpPr>
         <p:spPr>
           <a:xfrm>
-            <a:off x="365760" y="2560320"/>
+            <a:off x="411480" y="2560320"/>
             <a:ext cx="7040880" cy="1408176"/>
           </a:xfrm>
           <a:prstGeom prst="roundRect">
@@ -14462,7 +14462,7 @@
         </p:nvSpPr>
         <p:spPr>
           <a:xfrm>
-            <a:off x="365760" y="2560320"/>
+            <a:off x="411480" y="2560320"/>
             <a:ext cx="7040880" cy="384048"/>
           </a:xfrm>
           <a:prstGeom prst="roundRect">
@@ -14484,7 +14484,7 @@
         </p:nvSpPr>
         <p:spPr>
           <a:xfrm>
-            <a:off x="365760" y="2816352"/>
+            <a:off x="411480" y="2816352"/>
             <a:ext cx="7040880" cy="146304"/>
           </a:xfrm>
           <a:prstGeom prst="rect">
@@ -14504,7 +14504,7 @@
         </p:nvSpPr>
         <p:spPr>
           <a:xfrm>
-            <a:off x="365760" y="2560320"/>
+            <a:off x="411480" y="2560320"/>
             <a:ext cx="109728" cy="384048"/>
           </a:xfrm>
           <a:prstGeom prst="rect">
@@ -14524,7 +14524,7 @@
         </p:nvSpPr>
         <p:spPr>
           <a:xfrm>
-            <a:off x="594360" y="2560320"/>
+            <a:off x="640080" y="2560320"/>
             <a:ext cx="6583680" cy="384048"/>
           </a:xfrm>
           <a:prstGeom prst="rect">
@@ -14563,7 +14563,7 @@
         </p:nvSpPr>
         <p:spPr>
           <a:xfrm>
-            <a:off x="548640" y="3017520"/>
+            <a:off x="594360" y="3017520"/>
             <a:ext cx="6675120" cy="877824"/>
           </a:xfrm>
           <a:prstGeom prst="rect">
@@ -14602,7 +14602,7 @@
         </p:nvSpPr>
         <p:spPr>
           <a:xfrm>
-            <a:off x="365760" y="4078224"/>
+            <a:off x="411480" y="4078224"/>
             <a:ext cx="7040880" cy="1408176"/>
           </a:xfrm>
           <a:prstGeom prst="roundRect">
@@ -14636,7 +14636,7 @@
         </p:nvSpPr>
         <p:spPr>
           <a:xfrm>
-            <a:off x="365760" y="4078224"/>
+            <a:off x="411480" y="4078224"/>
             <a:ext cx="7040880" cy="384048"/>
           </a:xfrm>
           <a:prstGeom prst="roundRect">
@@ -14658,7 +14658,7 @@
         </p:nvSpPr>
         <p:spPr>
           <a:xfrm>
-            <a:off x="365760" y="4334256"/>
+            <a:off x="411480" y="4334256"/>
             <a:ext cx="7040880" cy="146304"/>
           </a:xfrm>
           <a:prstGeom prst="rect">
@@ -14678,7 +14678,7 @@
         </p:nvSpPr>
         <p:spPr>
           <a:xfrm>
-            <a:off x="365760" y="4078224"/>
+            <a:off x="411480" y="4078224"/>
             <a:ext cx="109728" cy="384048"/>
           </a:xfrm>
           <a:prstGeom prst="rect">
@@ -14698,7 +14698,7 @@
         </p:nvSpPr>
         <p:spPr>
           <a:xfrm>
-            <a:off x="594360" y="4078224"/>
+            <a:off x="640080" y="4078224"/>
             <a:ext cx="6583680" cy="384048"/>
           </a:xfrm>
           <a:prstGeom prst="rect">
@@ -14737,7 +14737,7 @@
         </p:nvSpPr>
         <p:spPr>
           <a:xfrm>
-            <a:off x="548640" y="4535424"/>
+            <a:off x="594360" y="4535424"/>
             <a:ext cx="6675120" cy="877824"/>
           </a:xfrm>
           <a:prstGeom prst="rect">
@@ -14890,8 +14890,8 @@
         </p:nvSpPr>
         <p:spPr>
           <a:xfrm>
-            <a:off x="365760" y="5614416"/>
-            <a:ext cx="11430000" cy="804672"/>
+            <a:off x="411480" y="5614416"/>
+            <a:ext cx="11338560" cy="804672"/>
           </a:xfrm>
           <a:prstGeom prst="roundRect">
             <a:avLst>
@@ -14924,7 +14924,7 @@
         </p:nvSpPr>
         <p:spPr>
           <a:xfrm>
-            <a:off x="365760" y="5614416"/>
+            <a:off x="411480" y="5614416"/>
             <a:ext cx="109728" cy="804672"/>
           </a:xfrm>
           <a:prstGeom prst="rect">
@@ -14944,8 +14944,8 @@
         </p:nvSpPr>
         <p:spPr>
           <a:xfrm>
-            <a:off x="640080" y="5669280"/>
-            <a:ext cx="10972800" cy="694944"/>
+            <a:off x="685800" y="5669280"/>
+            <a:ext cx="10881360" cy="694944"/>
           </a:xfrm>
           <a:prstGeom prst="rect">
             <a:avLst/>
@@ -18576,7 +18576,7 @@
         </p:nvSpPr>
         <p:spPr>
           <a:xfrm>
-            <a:off x="320040" y="1024128"/>
+            <a:off x="411480" y="1024128"/>
             <a:ext cx="7818120" cy="5394960"/>
           </a:xfrm>
           <a:prstGeom prst="rect">
@@ -18601,7 +18601,7 @@
         </p:nvSpPr>
         <p:spPr>
           <a:xfrm>
-            <a:off x="320040" y="1024128"/>
+            <a:off x="411480" y="1024128"/>
             <a:ext cx="7818120" cy="502920"/>
           </a:xfrm>
           <a:prstGeom prst="rect">
@@ -18621,7 +18621,7 @@
         </p:nvSpPr>
         <p:spPr>
           <a:xfrm>
-            <a:off x="320040" y="1024128"/>
+            <a:off x="411480" y="1024128"/>
             <a:ext cx="2514600" cy="502920"/>
           </a:xfrm>
           <a:prstGeom prst="rect">
@@ -18660,7 +18660,7 @@
         </p:nvSpPr>
         <p:spPr>
           <a:xfrm>
-            <a:off x="2834640" y="1024128"/>
+            <a:off x="2926080" y="1024128"/>
             <a:ext cx="5303520" cy="502920"/>
           </a:xfrm>
           <a:prstGeom prst="rect">
@@ -18699,7 +18699,7 @@
         </p:nvSpPr>
         <p:spPr>
           <a:xfrm>
-            <a:off x="2825496" y="1024128"/>
+            <a:off x="2916936" y="1024128"/>
             <a:ext cx="18288" cy="5394960"/>
           </a:xfrm>
           <a:prstGeom prst="rect">
@@ -18719,7 +18719,7 @@
         </p:nvSpPr>
         <p:spPr>
           <a:xfrm>
-            <a:off x="320040" y="1527048"/>
+            <a:off x="411480" y="1527048"/>
             <a:ext cx="2514600" cy="611505"/>
           </a:xfrm>
           <a:prstGeom prst="rect">
@@ -18739,7 +18739,7 @@
         </p:nvSpPr>
         <p:spPr>
           <a:xfrm>
-            <a:off x="2834640" y="1527048"/>
+            <a:off x="2926080" y="1527048"/>
             <a:ext cx="5303520" cy="611505"/>
           </a:xfrm>
           <a:prstGeom prst="rect">
@@ -18759,7 +18759,7 @@
         </p:nvSpPr>
         <p:spPr>
           <a:xfrm>
-            <a:off x="320040" y="2127580"/>
+            <a:off x="411480" y="2127580"/>
             <a:ext cx="7818120" cy="10973"/>
           </a:xfrm>
           <a:prstGeom prst="rect">
@@ -18779,7 +18779,7 @@
         </p:nvSpPr>
         <p:spPr>
           <a:xfrm>
-            <a:off x="393192" y="1527048"/>
+            <a:off x="484632" y="1527048"/>
             <a:ext cx="2368296" cy="611505"/>
           </a:xfrm>
           <a:prstGeom prst="rect">
@@ -18818,7 +18818,7 @@
         </p:nvSpPr>
         <p:spPr>
           <a:xfrm>
-            <a:off x="2980944" y="1563624"/>
+            <a:off x="3072384" y="1563624"/>
             <a:ext cx="5029200" cy="538353"/>
           </a:xfrm>
           <a:prstGeom prst="rect">
@@ -18857,7 +18857,7 @@
         </p:nvSpPr>
         <p:spPr>
           <a:xfrm>
-            <a:off x="320040" y="2138553"/>
+            <a:off x="411480" y="2138553"/>
             <a:ext cx="2514600" cy="611505"/>
           </a:xfrm>
           <a:prstGeom prst="rect">
@@ -18877,7 +18877,7 @@
         </p:nvSpPr>
         <p:spPr>
           <a:xfrm>
-            <a:off x="2834640" y="2138553"/>
+            <a:off x="2926080" y="2138553"/>
             <a:ext cx="5303520" cy="611505"/>
           </a:xfrm>
           <a:prstGeom prst="rect">
@@ -18897,7 +18897,7 @@
         </p:nvSpPr>
         <p:spPr>
           <a:xfrm>
-            <a:off x="320040" y="2739085"/>
+            <a:off x="411480" y="2739085"/>
             <a:ext cx="7818120" cy="10973"/>
           </a:xfrm>
           <a:prstGeom prst="rect">
@@ -18917,7 +18917,7 @@
         </p:nvSpPr>
         <p:spPr>
           <a:xfrm>
-            <a:off x="393192" y="2138553"/>
+            <a:off x="484632" y="2138553"/>
             <a:ext cx="2368296" cy="611505"/>
           </a:xfrm>
           <a:prstGeom prst="rect">
@@ -18956,7 +18956,7 @@
         </p:nvSpPr>
         <p:spPr>
           <a:xfrm>
-            <a:off x="2980944" y="2175129"/>
+            <a:off x="3072384" y="2175129"/>
             <a:ext cx="5029200" cy="538353"/>
           </a:xfrm>
           <a:prstGeom prst="rect">
@@ -18995,7 +18995,7 @@
         </p:nvSpPr>
         <p:spPr>
           <a:xfrm>
-            <a:off x="320040" y="2750058"/>
+            <a:off x="411480" y="2750058"/>
             <a:ext cx="2514600" cy="611505"/>
           </a:xfrm>
           <a:prstGeom prst="rect">
@@ -19015,7 +19015,7 @@
         </p:nvSpPr>
         <p:spPr>
           <a:xfrm>
-            <a:off x="2834640" y="2750058"/>
+            <a:off x="2926080" y="2750058"/>
             <a:ext cx="5303520" cy="611505"/>
           </a:xfrm>
           <a:prstGeom prst="rect">
@@ -19035,7 +19035,7 @@
         </p:nvSpPr>
         <p:spPr>
           <a:xfrm>
-            <a:off x="320040" y="3350590"/>
+            <a:off x="411480" y="3350590"/>
             <a:ext cx="7818120" cy="10973"/>
           </a:xfrm>
           <a:prstGeom prst="rect">
@@ -19055,7 +19055,7 @@
         </p:nvSpPr>
         <p:spPr>
           <a:xfrm>
-            <a:off x="393192" y="2750058"/>
+            <a:off x="484632" y="2750058"/>
             <a:ext cx="2368296" cy="611505"/>
           </a:xfrm>
           <a:prstGeom prst="rect">
@@ -19094,7 +19094,7 @@
         </p:nvSpPr>
         <p:spPr>
           <a:xfrm>
-            <a:off x="2980944" y="2786634"/>
+            <a:off x="3072384" y="2786634"/>
             <a:ext cx="5029200" cy="538353"/>
           </a:xfrm>
           <a:prstGeom prst="rect">
@@ -19147,7 +19147,7 @@
         </p:nvSpPr>
         <p:spPr>
           <a:xfrm>
-            <a:off x="320040" y="3361563"/>
+            <a:off x="411480" y="3361563"/>
             <a:ext cx="2514600" cy="611505"/>
           </a:xfrm>
           <a:prstGeom prst="rect">
@@ -19167,7 +19167,7 @@
         </p:nvSpPr>
         <p:spPr>
           <a:xfrm>
-            <a:off x="2834640" y="3361563"/>
+            <a:off x="2926080" y="3361563"/>
             <a:ext cx="5303520" cy="611505"/>
           </a:xfrm>
           <a:prstGeom prst="rect">
@@ -19187,7 +19187,7 @@
         </p:nvSpPr>
         <p:spPr>
           <a:xfrm>
-            <a:off x="320040" y="3962095"/>
+            <a:off x="411480" y="3962095"/>
             <a:ext cx="7818120" cy="10973"/>
           </a:xfrm>
           <a:prstGeom prst="rect">
@@ -19207,7 +19207,7 @@
         </p:nvSpPr>
         <p:spPr>
           <a:xfrm>
-            <a:off x="393192" y="3361563"/>
+            <a:off x="484632" y="3361563"/>
             <a:ext cx="2368296" cy="611505"/>
           </a:xfrm>
           <a:prstGeom prst="rect">
@@ -19246,7 +19246,7 @@
         </p:nvSpPr>
         <p:spPr>
           <a:xfrm>
-            <a:off x="2980944" y="3398139"/>
+            <a:off x="3072384" y="3398139"/>
             <a:ext cx="5029200" cy="538353"/>
           </a:xfrm>
           <a:prstGeom prst="rect">
@@ -19285,7 +19285,7 @@
         </p:nvSpPr>
         <p:spPr>
           <a:xfrm>
-            <a:off x="320040" y="3973068"/>
+            <a:off x="411480" y="3973068"/>
             <a:ext cx="2514600" cy="611505"/>
           </a:xfrm>
           <a:prstGeom prst="rect">
@@ -19305,7 +19305,7 @@
         </p:nvSpPr>
         <p:spPr>
           <a:xfrm>
-            <a:off x="2834640" y="3973068"/>
+            <a:off x="2926080" y="3973068"/>
             <a:ext cx="5303520" cy="611505"/>
           </a:xfrm>
           <a:prstGeom prst="rect">
@@ -19325,7 +19325,7 @@
         </p:nvSpPr>
         <p:spPr>
           <a:xfrm>
-            <a:off x="320040" y="4573600"/>
+            <a:off x="411480" y="4573600"/>
             <a:ext cx="7818120" cy="10973"/>
           </a:xfrm>
           <a:prstGeom prst="rect">
@@ -19345,7 +19345,7 @@
         </p:nvSpPr>
         <p:spPr>
           <a:xfrm>
-            <a:off x="393192" y="3973068"/>
+            <a:off x="484632" y="3973068"/>
             <a:ext cx="2368296" cy="611505"/>
           </a:xfrm>
           <a:prstGeom prst="rect">
@@ -19384,7 +19384,7 @@
         </p:nvSpPr>
         <p:spPr>
           <a:xfrm>
-            <a:off x="2980944" y="4009644"/>
+            <a:off x="3072384" y="4009644"/>
             <a:ext cx="5029200" cy="538353"/>
           </a:xfrm>
           <a:prstGeom prst="rect">
@@ -19423,7 +19423,7 @@
         </p:nvSpPr>
         <p:spPr>
           <a:xfrm>
-            <a:off x="320040" y="4584573"/>
+            <a:off x="411480" y="4584573"/>
             <a:ext cx="2514600" cy="611505"/>
           </a:xfrm>
           <a:prstGeom prst="rect">
@@ -19443,7 +19443,7 @@
         </p:nvSpPr>
         <p:spPr>
           <a:xfrm>
-            <a:off x="2834640" y="4584573"/>
+            <a:off x="2926080" y="4584573"/>
             <a:ext cx="5303520" cy="611505"/>
           </a:xfrm>
           <a:prstGeom prst="rect">
@@ -19463,7 +19463,7 @@
         </p:nvSpPr>
         <p:spPr>
           <a:xfrm>
-            <a:off x="320040" y="5185105"/>
+            <a:off x="411480" y="5185105"/>
             <a:ext cx="7818120" cy="10973"/>
           </a:xfrm>
           <a:prstGeom prst="rect">
@@ -19483,7 +19483,7 @@
         </p:nvSpPr>
         <p:spPr>
           <a:xfrm>
-            <a:off x="393192" y="4584573"/>
+            <a:off x="484632" y="4584573"/>
             <a:ext cx="2368296" cy="611505"/>
           </a:xfrm>
           <a:prstGeom prst="rect">
@@ -19522,7 +19522,7 @@
         </p:nvSpPr>
         <p:spPr>
           <a:xfrm>
-            <a:off x="2980944" y="4621149"/>
+            <a:off x="3072384" y="4621149"/>
             <a:ext cx="5029200" cy="538353"/>
           </a:xfrm>
           <a:prstGeom prst="rect">
@@ -19589,7 +19589,7 @@
         </p:nvSpPr>
         <p:spPr>
           <a:xfrm>
-            <a:off x="320040" y="5196078"/>
+            <a:off x="411480" y="5196078"/>
             <a:ext cx="2514600" cy="611505"/>
           </a:xfrm>
           <a:prstGeom prst="rect">
@@ -19609,7 +19609,7 @@
         </p:nvSpPr>
         <p:spPr>
           <a:xfrm>
-            <a:off x="2834640" y="5196078"/>
+            <a:off x="2926080" y="5196078"/>
             <a:ext cx="5303520" cy="611505"/>
           </a:xfrm>
           <a:prstGeom prst="rect">
@@ -19629,7 +19629,7 @@
         </p:nvSpPr>
         <p:spPr>
           <a:xfrm>
-            <a:off x="320040" y="5796610"/>
+            <a:off x="411480" y="5796610"/>
             <a:ext cx="7818120" cy="10973"/>
           </a:xfrm>
           <a:prstGeom prst="rect">
@@ -19649,7 +19649,7 @@
         </p:nvSpPr>
         <p:spPr>
           <a:xfrm>
-            <a:off x="393192" y="5196078"/>
+            <a:off x="484632" y="5196078"/>
             <a:ext cx="2368296" cy="611505"/>
           </a:xfrm>
           <a:prstGeom prst="rect">
@@ -19688,7 +19688,7 @@
         </p:nvSpPr>
         <p:spPr>
           <a:xfrm>
-            <a:off x="2980944" y="5232654"/>
+            <a:off x="3072384" y="5232654"/>
             <a:ext cx="5029200" cy="538353"/>
           </a:xfrm>
           <a:prstGeom prst="rect">
@@ -19741,7 +19741,7 @@
         </p:nvSpPr>
         <p:spPr>
           <a:xfrm>
-            <a:off x="320040" y="5807583"/>
+            <a:off x="411480" y="5807583"/>
             <a:ext cx="2514600" cy="611505"/>
           </a:xfrm>
           <a:prstGeom prst="rect">
@@ -19761,7 +19761,7 @@
         </p:nvSpPr>
         <p:spPr>
           <a:xfrm>
-            <a:off x="2834640" y="5807583"/>
+            <a:off x="2926080" y="5807583"/>
             <a:ext cx="5303520" cy="611505"/>
           </a:xfrm>
           <a:prstGeom prst="rect">
@@ -19781,7 +19781,7 @@
         </p:nvSpPr>
         <p:spPr>
           <a:xfrm>
-            <a:off x="320040" y="6408115"/>
+            <a:off x="411480" y="6408115"/>
             <a:ext cx="7818120" cy="10973"/>
           </a:xfrm>
           <a:prstGeom prst="rect">
@@ -19801,7 +19801,7 @@
         </p:nvSpPr>
         <p:spPr>
           <a:xfrm>
-            <a:off x="393192" y="5807583"/>
+            <a:off x="484632" y="5807583"/>
             <a:ext cx="2368296" cy="611505"/>
           </a:xfrm>
           <a:prstGeom prst="rect">
@@ -19840,7 +19840,7 @@
         </p:nvSpPr>
         <p:spPr>
           <a:xfrm>
-            <a:off x="2980944" y="5844159"/>
+            <a:off x="3072384" y="5844159"/>
             <a:ext cx="5029200" cy="538353"/>
           </a:xfrm>
           <a:prstGeom prst="rect">

</xml_diff>